<commit_message>
Finalize presentation cover and remove obsolete decks
</commit_message>
<xml_diff>
--- a/presentacion_final_ligo_5min.pptx
+++ b/presentacion_final_ligo_5min.pptx
@@ -11,6 +11,7 @@
     <p:sldId id="259" r:id="rId11"/>
     <p:sldId id="260" r:id="rId12"/>
     <p:sldId id="261" r:id="rId13"/>
+    <p:sldId id="262" r:id="rId14"/>
   </p:sldIdLst>
   <p:sldSz cx="12191695" cy="6858000" type="screen4x3"/>
   <p:notesSz cx="6858000" cy="9144000"/>
@@ -858,6 +859,76 @@
           <a:p>
             <a:r>
               <a:t>25 s. Cerrar con el mensaje principal y el próximo paso concreto: una campaña de inyecciones completa. Abrir preguntas.</a:t>
+            </a:r>
+          </a:p>
+        </p:txBody>
+      </p:sp>
+      <p:sp>
+        <p:nvSpPr>
+          <p:cNvPr id="4" name="Slide Number Placeholder 3"/>
+          <p:cNvSpPr>
+            <a:spLocks noGrp="1"/>
+          </p:cNvSpPr>
+          <p:nvPr>
+            <p:ph type="sldNum" idx="5" sz="quarter"/>
+          </p:nvPr>
+        </p:nvSpPr>
+        <p:spPr/>
+      </p:sp>
+    </p:spTree>
+  </p:cSld>
+  <p:clrMapOvr>
+    <a:masterClrMapping/>
+  </p:clrMapOvr>
+</p:notes>
+</file>
+
+<file path=ppt/notesSlides/notesSlide7.xml><?xml version="1.0" encoding="utf-8"?>
+<p:notes xmlns:a="http://schemas.openxmlformats.org/drawingml/2006/main" xmlns:p="http://schemas.openxmlformats.org/presentationml/2006/main" xmlns:r="http://schemas.openxmlformats.org/officeDocument/2006/relationships">
+  <p:cSld>
+    <p:spTree>
+      <p:nvGrpSpPr>
+        <p:cNvPr id="1" name=""/>
+        <p:cNvGrpSpPr/>
+        <p:nvPr/>
+      </p:nvGrpSpPr>
+      <p:grpSpPr>
+        <a:xfrm>
+          <a:off x="0" y="0"/>
+          <a:ext cx="0" cy="0"/>
+          <a:chOff x="0" y="0"/>
+          <a:chExt cx="0" cy="0"/>
+        </a:xfrm>
+      </p:grpSpPr>
+      <p:sp>
+        <p:nvSpPr>
+          <p:cNvPr id="2" name="Slide Image Placeholder 1"/>
+          <p:cNvSpPr>
+            <a:spLocks noGrp="1"/>
+          </p:cNvSpPr>
+          <p:nvPr>
+            <p:ph type="sldImg" idx="2"/>
+          </p:nvPr>
+        </p:nvSpPr>
+        <p:spPr/>
+      </p:sp>
+      <p:sp>
+        <p:nvSpPr>
+          <p:cNvPr id="3" name="Notes Placeholder 2"/>
+          <p:cNvSpPr>
+            <a:spLocks noGrp="1"/>
+          </p:cNvSpPr>
+          <p:nvPr>
+            <p:ph type="body" idx="3" sz="quarter"/>
+          </p:nvPr>
+        </p:nvSpPr>
+        <p:spPr/>
+        <p:txBody>
+          <a:bodyPr/>
+          <a:lstStyle/>
+          <a:p>
+            <a:r>
+              <a:t>Dejar esta diapositiva visible durante las preguntas. No hace falta decir más que: gracias por escucharnos; esperamos sus preguntas.</a:t>
             </a:r>
           </a:p>
         </p:txBody>
@@ -3958,8 +4029,8 @@
         </p:nvSpPr>
         <p:spPr>
           <a:xfrm>
-            <a:off x="713232" y="1417320"/>
-            <a:ext cx="9875520" cy="1554480"/>
+            <a:off x="713232" y="1298448"/>
+            <a:ext cx="10469880" cy="1691640"/>
           </a:xfrm>
           <a:prstGeom prst="rect">
             <a:avLst/>
@@ -3973,7 +4044,7 @@
           <a:lstStyle/>
           <a:p>
             <a:pPr algn="l">
-              <a:defRPr sz="3500" b="1">
+              <a:defRPr sz="3100" b="1">
                 <a:solidFill>
                   <a:srgbClr val="F7F9FC"/>
                 </a:solidFill>
@@ -3981,11 +4052,11 @@
               </a:defRPr>
             </a:pPr>
             <a:r>
-              <a:t>¿Qué fusiones de agujeros negros</a:t>
+              <a:t>¿De qué es ciego LIGO?</a:t>
             </a:r>
             <a:br/>
             <a:r>
-              <a:t>puede ver LIGO?</a:t>
+              <a:t>Efectos de selección en el catálogo de fusiones</a:t>
             </a:r>
           </a:p>
         </p:txBody>
@@ -3998,8 +4069,8 @@
         </p:nvSpPr>
         <p:spPr>
           <a:xfrm>
-            <a:off x="749808" y="3246120"/>
-            <a:ext cx="6583680" cy="777240"/>
+            <a:off x="749808" y="3273552"/>
+            <a:ext cx="9784080" cy="384048"/>
           </a:xfrm>
           <a:prstGeom prst="rect">
             <a:avLst/>
@@ -4013,7 +4084,7 @@
           <a:lstStyle/>
           <a:p>
             <a:pPr algn="l">
-              <a:defRPr sz="2100" b="0">
+              <a:defRPr sz="1700" b="0">
                 <a:solidFill>
                   <a:srgbClr val="BDCAD8"/>
                 </a:solidFill>
@@ -4021,11 +4092,7 @@
               </a:defRPr>
             </a:pPr>
             <a:r>
-              <a:t>Sesgo de selección y observabilidad</a:t>
-            </a:r>
-            <a:br/>
-            <a:r>
-              <a:t>en el caso GW150914</a:t>
+              <a:t>Proyecto final · Ondas Gravitacionales e Investigación Asistida por IA</a:t>
             </a:r>
           </a:p>
         </p:txBody>
@@ -4082,7 +4149,7 @@
         <p:spPr>
           <a:xfrm>
             <a:off x="749808" y="5074920"/>
-            <a:ext cx="4572000" cy="594360"/>
+            <a:ext cx="5303520" cy="594360"/>
           </a:xfrm>
           <a:prstGeom prst="rect">
             <a:avLst/>
@@ -7343,6 +7410,298 @@
             </a:pPr>
             <a:r>
               <a:t>Gracias</a:t>
+            </a:r>
+          </a:p>
+        </p:txBody>
+      </p:sp>
+    </p:spTree>
+  </p:cSld>
+  <p:clrMapOvr>
+    <a:masterClrMapping/>
+  </p:clrMapOvr>
+</p:sld>
+</file>
+
+<file path=ppt/slides/slide7.xml><?xml version="1.0" encoding="utf-8"?>
+<p:sld xmlns:a="http://schemas.openxmlformats.org/drawingml/2006/main" xmlns:p="http://schemas.openxmlformats.org/presentationml/2006/main" xmlns:r="http://schemas.openxmlformats.org/officeDocument/2006/relationships">
+  <p:cSld>
+    <p:bg>
+      <p:bgPr>
+        <a:solidFill>
+          <a:srgbClr val="0C182B"/>
+        </a:solidFill>
+        <a:effectLst/>
+      </p:bgPr>
+    </p:bg>
+    <p:spTree>
+      <p:nvGrpSpPr>
+        <p:cNvPr id="1" name=""/>
+        <p:cNvGrpSpPr/>
+        <p:nvPr/>
+      </p:nvGrpSpPr>
+      <p:grpSpPr/>
+      <p:sp>
+        <p:nvSpPr>
+          <p:cNvPr id="2" name="Rounded Rectangle 1"/>
+          <p:cNvSpPr/>
+          <p:nvPr/>
+        </p:nvSpPr>
+        <p:spPr>
+          <a:xfrm>
+            <a:off x="713232" y="914400"/>
+            <a:ext cx="1737360" cy="310896"/>
+          </a:xfrm>
+          <a:prstGeom prst="roundRect">
+            <a:avLst/>
+          </a:prstGeom>
+          <a:solidFill>
+            <a:srgbClr val="30B5A4"/>
+          </a:solidFill>
+          <a:ln>
+            <a:noFill/>
+          </a:ln>
+        </p:spPr>
+        <p:style>
+          <a:lnRef idx="1">
+            <a:schemeClr val="accent1"/>
+          </a:lnRef>
+          <a:fillRef idx="3">
+            <a:schemeClr val="accent1"/>
+          </a:fillRef>
+          <a:effectRef idx="2">
+            <a:schemeClr val="accent1"/>
+          </a:effectRef>
+          <a:fontRef idx="minor">
+            <a:schemeClr val="lt1"/>
+          </a:fontRef>
+        </p:style>
+        <p:txBody>
+          <a:bodyPr rtlCol="0" anchor="ctr"/>
+          <a:lstStyle/>
+          <a:p>
+            <a:pPr algn="ctr"/>
+          </a:p>
+        </p:txBody>
+      </p:sp>
+      <p:sp>
+        <p:nvSpPr>
+          <p:cNvPr id="3" name="TextBox 2"/>
+          <p:cNvSpPr txBox="1"/>
+          <p:nvPr/>
+        </p:nvSpPr>
+        <p:spPr>
+          <a:xfrm>
+            <a:off x="777240" y="896112"/>
+            <a:ext cx="1600200" cy="320040"/>
+          </a:xfrm>
+          <a:prstGeom prst="rect">
+            <a:avLst/>
+          </a:prstGeom>
+          <a:noFill/>
+        </p:spPr>
+        <p:txBody>
+          <a:bodyPr wrap="none" lIns="0" rIns="0" tIns="0" bIns="0" anchor="ctr">
+            <a:spAutoFit/>
+          </a:bodyPr>
+          <a:lstStyle/>
+          <a:p>
+            <a:pPr algn="ctr">
+              <a:defRPr sz="1000" b="1">
+                <a:solidFill>
+                  <a:srgbClr val="0C182B"/>
+                </a:solidFill>
+                <a:latin typeface="Aptos"/>
+              </a:defRPr>
+            </a:pPr>
+            <a:r>
+              <a:t>PROYECTO FINAL</a:t>
+            </a:r>
+          </a:p>
+        </p:txBody>
+      </p:sp>
+      <p:sp>
+        <p:nvSpPr>
+          <p:cNvPr id="4" name="TextBox 3"/>
+          <p:cNvSpPr txBox="1"/>
+          <p:nvPr/>
+        </p:nvSpPr>
+        <p:spPr>
+          <a:xfrm>
+            <a:off x="914400" y="2148840"/>
+            <a:ext cx="10332720" cy="685800"/>
+          </a:xfrm>
+          <a:prstGeom prst="rect">
+            <a:avLst/>
+          </a:prstGeom>
+          <a:noFill/>
+        </p:spPr>
+        <p:txBody>
+          <a:bodyPr wrap="none" lIns="0" rIns="0" tIns="0" bIns="0" anchor="ctr">
+            <a:spAutoFit/>
+          </a:bodyPr>
+          <a:lstStyle/>
+          <a:p>
+            <a:pPr algn="ctr">
+              <a:defRPr sz="3500" b="1">
+                <a:solidFill>
+                  <a:srgbClr val="F7F9FC"/>
+                </a:solidFill>
+                <a:latin typeface="Aptos"/>
+              </a:defRPr>
+            </a:pPr>
+            <a:r>
+              <a:t>Gracias por escucharnos</a:t>
+            </a:r>
+          </a:p>
+        </p:txBody>
+      </p:sp>
+      <p:sp>
+        <p:nvSpPr>
+          <p:cNvPr id="5" name="TextBox 4"/>
+          <p:cNvSpPr txBox="1"/>
+          <p:nvPr/>
+        </p:nvSpPr>
+        <p:spPr>
+          <a:xfrm>
+            <a:off x="914400" y="3063240"/>
+            <a:ext cx="10332720" cy="411480"/>
+          </a:xfrm>
+          <a:prstGeom prst="rect">
+            <a:avLst/>
+          </a:prstGeom>
+          <a:noFill/>
+        </p:spPr>
+        <p:txBody>
+          <a:bodyPr wrap="none" lIns="0" rIns="0" tIns="0" bIns="0" anchor="ctr">
+            <a:spAutoFit/>
+          </a:bodyPr>
+          <a:lstStyle/>
+          <a:p>
+            <a:pPr algn="ctr">
+              <a:defRPr sz="2100" b="0">
+                <a:solidFill>
+                  <a:srgbClr val="30B5A4"/>
+                </a:solidFill>
+                <a:latin typeface="Aptos"/>
+              </a:defRPr>
+            </a:pPr>
+            <a:r>
+              <a:t>Esperamos sus preguntas</a:t>
+            </a:r>
+          </a:p>
+        </p:txBody>
+      </p:sp>
+      <p:sp>
+        <p:nvSpPr>
+          <p:cNvPr id="6" name="Rectangle 5"/>
+          <p:cNvSpPr/>
+          <p:nvPr/>
+        </p:nvSpPr>
+        <p:spPr>
+          <a:xfrm>
+            <a:off x="4343400" y="4005072"/>
+            <a:ext cx="3520440" cy="64008"/>
+          </a:xfrm>
+          <a:prstGeom prst="rect">
+            <a:avLst/>
+          </a:prstGeom>
+          <a:solidFill>
+            <a:srgbClr val="F17E3D"/>
+          </a:solidFill>
+          <a:ln>
+            <a:noFill/>
+          </a:ln>
+        </p:spPr>
+        <p:style>
+          <a:lnRef idx="1">
+            <a:schemeClr val="accent1"/>
+          </a:lnRef>
+          <a:fillRef idx="3">
+            <a:schemeClr val="accent1"/>
+          </a:fillRef>
+          <a:effectRef idx="2">
+            <a:schemeClr val="accent1"/>
+          </a:effectRef>
+          <a:fontRef idx="minor">
+            <a:schemeClr val="lt1"/>
+          </a:fontRef>
+        </p:style>
+        <p:txBody>
+          <a:bodyPr rtlCol="0" anchor="ctr"/>
+          <a:lstStyle/>
+          <a:p>
+            <a:pPr algn="ctr"/>
+          </a:p>
+        </p:txBody>
+      </p:sp>
+      <p:sp>
+        <p:nvSpPr>
+          <p:cNvPr id="7" name="TextBox 6"/>
+          <p:cNvSpPr txBox="1"/>
+          <p:nvPr/>
+        </p:nvSpPr>
+        <p:spPr>
+          <a:xfrm>
+            <a:off x="914400" y="4800600"/>
+            <a:ext cx="10332720" cy="365760"/>
+          </a:xfrm>
+          <a:prstGeom prst="rect">
+            <a:avLst/>
+          </a:prstGeom>
+          <a:noFill/>
+        </p:spPr>
+        <p:txBody>
+          <a:bodyPr wrap="none" lIns="0" rIns="0" tIns="0" bIns="0" anchor="ctr">
+            <a:spAutoFit/>
+          </a:bodyPr>
+          <a:lstStyle/>
+          <a:p>
+            <a:pPr algn="ctr">
+              <a:defRPr sz="1600" b="0">
+                <a:solidFill>
+                  <a:srgbClr val="BDCAD8"/>
+                </a:solidFill>
+                <a:latin typeface="Aptos"/>
+              </a:defRPr>
+            </a:pPr>
+            <a:r>
+              <a:t>Tomás Carpintieri · Agustín Miculicich</a:t>
+            </a:r>
+          </a:p>
+        </p:txBody>
+      </p:sp>
+      <p:sp>
+        <p:nvSpPr>
+          <p:cNvPr id="8" name="TextBox 7"/>
+          <p:cNvSpPr txBox="1"/>
+          <p:nvPr/>
+        </p:nvSpPr>
+        <p:spPr>
+          <a:xfrm>
+            <a:off x="914400" y="5257800"/>
+            <a:ext cx="10332720" cy="320040"/>
+          </a:xfrm>
+          <a:prstGeom prst="rect">
+            <a:avLst/>
+          </a:prstGeom>
+          <a:noFill/>
+        </p:spPr>
+        <p:txBody>
+          <a:bodyPr wrap="none" lIns="0" rIns="0" tIns="0" bIns="0" anchor="ctr">
+            <a:spAutoFit/>
+          </a:bodyPr>
+          <a:lstStyle/>
+          <a:p>
+            <a:pPr algn="ctr">
+              <a:defRPr sz="1400" b="0">
+                <a:solidFill>
+                  <a:srgbClr val="BDCAD8"/>
+                </a:solidFill>
+                <a:latin typeface="Aptos"/>
+              </a:defRPr>
+            </a:pPr>
+            <a:r>
+              <a:t>Universidad de Buenos Aires</a:t>
             </a:r>
           </a:p>
         </p:txBody>

</xml_diff>

<commit_message>
Fix final presentation closing slide layout
</commit_message>
<xml_diff>
--- a/presentacion_final_ligo_5min.pptx
+++ b/presentacion_final_ligo_5min.pptx
@@ -7186,7 +7186,7 @@
               </a:defRPr>
             </a:pPr>
             <a:r>
-              <a:t>Para estudiar poblaciones, primero hay que modelar qué deja pasar el detector</a:t>
+              <a:t>Modelar la selección es el primer paso</a:t>
             </a:r>
           </a:p>
         </p:txBody>
@@ -7350,8 +7350,8 @@
         </p:nvSpPr>
         <p:spPr>
           <a:xfrm>
-            <a:off x="914400" y="4187952"/>
-            <a:ext cx="9738360" cy="612648"/>
+            <a:off x="914400" y="4096512"/>
+            <a:ext cx="9738360" cy="960120"/>
           </a:xfrm>
           <a:prstGeom prst="rect">
             <a:avLst/>
@@ -7365,7 +7365,7 @@
           <a:lstStyle/>
           <a:p>
             <a:pPr algn="l">
-              <a:defRPr sz="2400" b="1">
+              <a:defRPr sz="2000" b="1">
                 <a:solidFill>
                   <a:srgbClr val="F7F9FC"/>
                 </a:solidFill>

</xml_diff>

<commit_message>
Complete selection analysis audit fixes
</commit_message>
<xml_diff>
--- a/presentacion_final_ligo_5min.pptx
+++ b/presentacion_final_ligo_5min.pptx
@@ -718,7 +718,7 @@
           <a:lstStyle/>
           <a:p>
             <a:r>
-              <a:t>55 s. Mostrar el pico en ambos detectores. El test de control recupera SNR 19.81 en Hanford y 13.54 en Livingston, con el retraso esperado. También contrastamos nuestra waveform con LAL: match 1.000.</a:t>
+              <a:t>55 s. Mostrar el pico en ambos detectores. El test de control recupera SNR 19.81 en Hanford y 13.54 en Livingston, con el retraso esperado. También contrastamos nuestra waveform con LAL: match 1.000. La geometría de los sitios da un máximo de 10.013 ms; el retardo de este evento es menor y solo delimita un anillo en el cielo.</a:t>
             </a:r>
           </a:p>
         </p:txBody>
@@ -788,7 +788,7 @@
           <a:lstStyle/>
           <a:p>
             <a:r>
-              <a:t>45 s. Esta fue la dificultad y el aprendizaje del proyecto: no aceptar un número solo porque parece razonable. El pipeline tiene datos hasheados, tests y procedencia. Una limitación importante: inspiral-only subestima la detectabilidad de sistemas pesados como GW150914.</a:t>
+              <a:t>45 s. Esta fue la dificultad y el aprendizaje del proyecto: un test reveló que el corte de inspiral estaba apagado y otro que la normalización de whitening daba 0.442 en vez de 0.965. No se aflojó ningún margen: se buscó la causa y se llegó a 0.959. El pipeline tiene datos hasheados, tests y procedencia. TaylorF2 inspiral-only sigue siendo una limitación declarada.</a:t>
             </a:r>
           </a:p>
         </p:txBody>
@@ -5260,7 +5260,7 @@
               </a:defRPr>
             </a:pPr>
             <a:r>
-              <a:t>1 969.9</a:t>
+              <a:t>1,969.9</a:t>
             </a:r>
           </a:p>
         </p:txBody>
@@ -6216,7 +6216,7 @@
               </a:defRPr>
             </a:pPr>
             <a:r>
-              <a:t>−7.08 ms</a:t>
+              <a:t>-7.08 ms</a:t>
             </a:r>
           </a:p>
         </p:txBody>
@@ -6289,6 +6289,42 @@
             </a:pPr>
             <a:r>
               <a:t>Además: match de waveform frente a LAL = 1.000</a:t>
+            </a:r>
+          </a:p>
+        </p:txBody>
+      </p:sp>
+      <p:sp>
+        <p:nvSpPr>
+          <p:cNvPr id="18" name="TextBox 17"/>
+          <p:cNvSpPr txBox="1"/>
+          <p:nvPr/>
+        </p:nvSpPr>
+        <p:spPr>
+          <a:xfrm>
+            <a:off x="7882127" y="5961888"/>
+            <a:ext cx="3127248" cy="256032"/>
+          </a:xfrm>
+          <a:prstGeom prst="rect">
+            <a:avLst/>
+          </a:prstGeom>
+          <a:noFill/>
+        </p:spPr>
+        <p:txBody>
+          <a:bodyPr wrap="none" lIns="0" rIns="0" tIns="0" bIns="0" anchor="ctr">
+            <a:spAutoFit/>
+          </a:bodyPr>
+          <a:lstStyle/>
+          <a:p>
+            <a:pPr algn="ctr">
+              <a:defRPr sz="1000" b="0">
+                <a:solidFill>
+                  <a:srgbClr val="BDCAD8"/>
+                </a:solidFill>
+                <a:latin typeface="Aptos"/>
+              </a:defRPr>
+            </a:pPr>
+            <a:r>
+              <a:t>Máximo retardo geométrico H1–L1 = 10.013 ms</a:t>
             </a:r>
           </a:p>
         </p:txBody>
@@ -6771,7 +6807,7 @@
               </a:defRPr>
             </a:pPr>
             <a:r>
-              <a:t>Tests antes que conclusiones</a:t>
+              <a:t>Un fallo nos frenó</a:t>
             </a:r>
           </a:p>
         </p:txBody>
@@ -6807,11 +6843,11 @@
               </a:defRPr>
             </a:pPr>
             <a:r>
-              <a:t>39 controles automáticos</a:t>
+              <a:t>el corte inspiral estaba</a:t>
             </a:r>
             <a:br/>
             <a:r>
-              <a:t>y figuras regenerables</a:t>
+              <a:t>desactivado; lo detectó un test</a:t>
             </a:r>
           </a:p>
         </p:txBody>
@@ -6926,7 +6962,7 @@
               </a:defRPr>
             </a:pPr>
             <a:r>
-              <a:t>Límites declarados</a:t>
+              <a:t>No aflojamos el margen</a:t>
             </a:r>
           </a:p>
         </p:txBody>
@@ -6962,11 +6998,11 @@
               </a:defRPr>
             </a:pPr>
             <a:r>
-              <a:t>TaylorF2 subestima</a:t>
+              <a:t>la varianza whitening</a:t>
             </a:r>
             <a:br/>
             <a:r>
-              <a:t>sistemas pesados</a:t>
+              <a:t>0.442 se corrigió a 0.959</a:t>
             </a:r>
           </a:p>
         </p:txBody>

</xml_diff>

<commit_message>
Add reproducible network injection pilot
</commit_message>
<xml_diff>
--- a/presentacion_final_ligo_5min.pptx
+++ b/presentacion_final_ligo_5min.pptx
@@ -858,7 +858,7 @@
           <a:lstStyle/>
           <a:p>
             <a:r>
-              <a:t>25 s. Cerrar con el mensaje principal y el próximo paso concreto: una campaña de inyecciones completa. Abrir preguntas.</a:t>
+              <a:t>25 s. Cerrar con el resultado: el catálogo favorece fuentes cercanas, masivas y bien orientadas. El piloto en ruido real recuperó 39.6% frente a 4.2% de fondo. Aclarar que el próximo paso es IMR para cubrir bien sistemas pesados. Abrir preguntas.</a:t>
             </a:r>
           </a:p>
         </p:txBody>
@@ -7350,8 +7350,8 @@
         </p:nvSpPr>
         <p:spPr>
           <a:xfrm>
-            <a:off x="914400" y="3703320"/>
-            <a:ext cx="2743200" cy="384048"/>
+            <a:off x="914400" y="3182112"/>
+            <a:ext cx="10241280" cy="365760"/>
           </a:xfrm>
           <a:prstGeom prst="rect">
             <a:avLst/>
@@ -7364,16 +7364,16 @@
           </a:bodyPr>
           <a:lstStyle/>
           <a:p>
-            <a:pPr algn="l">
-              <a:defRPr sz="1400" b="1">
-                <a:solidFill>
-                  <a:srgbClr val="30B5A4"/>
+            <a:pPr algn="ctr">
+              <a:defRPr sz="1300" b="1">
+                <a:solidFill>
+                  <a:srgbClr val="BDCAD8"/>
                 </a:solidFill>
                 <a:latin typeface="Aptos"/>
               </a:defRPr>
             </a:pPr>
             <a:r>
-              <a:t>Siguiente paso</a:t>
+              <a:t>Hallazgo: favorece fuentes cercanas, más masivas y bien orientadas. El piloto recuperó 39.6% de inyecciones, frente a 4.2% de fondo.</a:t>
             </a:r>
           </a:p>
         </p:txBody>
@@ -7386,8 +7386,8 @@
         </p:nvSpPr>
         <p:spPr>
           <a:xfrm>
-            <a:off x="914400" y="4096512"/>
-            <a:ext cx="9738360" cy="960120"/>
+            <a:off x="914400" y="3703320"/>
+            <a:ext cx="2743200" cy="384048"/>
           </a:xfrm>
           <a:prstGeom prst="rect">
             <a:avLst/>
@@ -7401,6 +7401,42 @@
           <a:lstStyle/>
           <a:p>
             <a:pPr algn="l">
+              <a:defRPr sz="1400" b="1">
+                <a:solidFill>
+                  <a:srgbClr val="30B5A4"/>
+                </a:solidFill>
+                <a:latin typeface="Aptos"/>
+              </a:defRPr>
+            </a:pPr>
+            <a:r>
+              <a:t>Siguiente paso</a:t>
+            </a:r>
+          </a:p>
+        </p:txBody>
+      </p:sp>
+      <p:sp>
+        <p:nvSpPr>
+          <p:cNvPr id="10" name="TextBox 9"/>
+          <p:cNvSpPr txBox="1"/>
+          <p:nvPr/>
+        </p:nvSpPr>
+        <p:spPr>
+          <a:xfrm>
+            <a:off x="914400" y="4096512"/>
+            <a:ext cx="9738360" cy="960120"/>
+          </a:xfrm>
+          <a:prstGeom prst="rect">
+            <a:avLst/>
+          </a:prstGeom>
+          <a:noFill/>
+        </p:spPr>
+        <p:txBody>
+          <a:bodyPr wrap="none" lIns="0" rIns="0" tIns="0" bIns="0" anchor="ctr">
+            <a:spAutoFit/>
+          </a:bodyPr>
+          <a:lstStyle/>
+          <a:p>
+            <a:pPr algn="l">
               <a:defRPr sz="2000" b="1">
                 <a:solidFill>
                   <a:srgbClr val="F7F9FC"/>
@@ -7409,14 +7445,14 @@
               </a:defRPr>
             </a:pPr>
             <a:r>
-              <a:t>Campaña de inyecciones: simular una población, insertarla en datos reales y medir qué fracción recupera la red.</a:t>
-            </a:r>
-          </a:p>
-        </p:txBody>
-      </p:sp>
-      <p:sp>
-        <p:nvSpPr>
-          <p:cNvPr id="10" name="TextBox 9"/>
+              <a:t>Campaña IMR: ampliar la población, incluir fusión y ringdown, y medir la función de selección de la red.</a:t>
+            </a:r>
+          </a:p>
+        </p:txBody>
+      </p:sp>
+      <p:sp>
+        <p:nvSpPr>
+          <p:cNvPr id="11" name="TextBox 10"/>
           <p:cNvSpPr txBox="1"/>
           <p:nvPr/>
         </p:nvSpPr>

</xml_diff>